<commit_message>
Switch alert channel back to Slack across NOVA diagram and deck
The team's alert integration is Slack, not Discord.
- drawio: restore original "Slack #alert" button and Slack logo; re-export PNG
- slide 5: embed re-exported architecture image
- slide 14: remove Discord overlay shapes so the underlying Slack graphic shows; title now "Slack 알림"
- slide 15: verification row reads "Slack 연동 확인"

Co-Authored-By: Claude Opus 5.5 <noreply@anthropic.com>
Claude-Session: https://claude.ai/code/session_014rLHkFruFY9PfBC7ikz3eW
</commit_message>
<xml_diff>
--- a/out/NOVA_v16.pptx
+++ b/out/NOVA_v16.pptx
@@ -14910,7 +14910,7 @@
                 <a:cs typeface="Calibri"/>
                 <a:sym typeface="Calibri"/>
               </a:rPr>
-              <a:t>Logging · Uptime · Discord 알림</a:t>
+              <a:t>Logging · Uptime · Slack 알림</a:t>
             </a:r>
             <a:endParaRPr/>
           </a:p>
@@ -15485,167 +15485,6 @@
           </a:ln>
         </p:spPr>
       </p:pic>
-      <p:sp>
-        <p:nvSpPr>
-          <p:cNvPr id="901" name="Discord cover"/>
-          <p:cNvSpPr/>
-          <p:nvPr/>
-        </p:nvSpPr>
-        <p:spPr>
-          <a:xfrm>
-            <a:off x="7164324" y="3291840"/>
-            <a:ext cx="1046988" cy="1956816"/>
-          </a:xfrm>
-          <a:prstGeom prst="rect">
-            <a:avLst/>
-          </a:prstGeom>
-          <a:solidFill>
-            <a:srgbClr val="FFFFFF"/>
-          </a:solidFill>
-          <a:ln>
-            <a:noFill/>
-          </a:ln>
-        </p:spPr>
-        <p:txBody>
-          <a:bodyPr wrap="none" lIns="0" tIns="0" rIns="0" bIns="0" anchor="ctr"/>
-          <a:lstStyle/>
-          <a:p>
-            <a:endParaRPr lang="ko-KR"/>
-          </a:p>
-        </p:txBody>
-      </p:sp>
-      <p:sp>
-        <p:nvSpPr>
-          <p:cNvPr id="902" name="Discord alert"/>
-          <p:cNvSpPr/>
-          <p:nvPr/>
-        </p:nvSpPr>
-        <p:spPr>
-          <a:xfrm>
-            <a:off x="7187184" y="3383280"/>
-            <a:ext cx="886968" cy="1179576"/>
-          </a:xfrm>
-          <a:prstGeom prst="roundRect">
-            <a:avLst>
-              <a:gd name="adj" fmla="val 22000"/>
-            </a:avLst>
-          </a:prstGeom>
-          <a:solidFill>
-            <a:srgbClr val="5865F2"/>
-          </a:solidFill>
-          <a:ln>
-            <a:noFill/>
-          </a:ln>
-        </p:spPr>
-        <p:txBody>
-          <a:bodyPr wrap="none" lIns="0" tIns="0" rIns="0" bIns="0" anchor="ctr"/>
-          <a:lstStyle/>
-          <a:p>
-            <a:pPr algn="ctr"/>
-            <a:r>
-              <a:rPr lang="ko-KR" sz="2800" b="1">
-                <a:solidFill>
-                  <a:srgbClr val="FFFFFF"/>
-                </a:solidFill>
-                <a:latin typeface="Calibri"/>
-                <a:ea typeface="Calibri"/>
-              </a:rPr>
-              <a:t>#</a:t>
-            </a:r>
-          </a:p>
-          <a:p>
-            <a:pPr algn="ctr"/>
-            <a:r>
-              <a:rPr lang="ko-KR" sz="1600" b="1">
-                <a:solidFill>
-                  <a:srgbClr val="FFFFFF"/>
-                </a:solidFill>
-                <a:latin typeface="Calibri"/>
-                <a:ea typeface="Calibri"/>
-              </a:rPr>
-              <a:t>alert</a:t>
-            </a:r>
-          </a:p>
-        </p:txBody>
-      </p:sp>
-      <p:sp>
-        <p:nvSpPr>
-          <p:cNvPr id="903" name="Discord label"/>
-          <p:cNvSpPr/>
-          <p:nvPr/>
-        </p:nvSpPr>
-        <p:spPr>
-          <a:xfrm>
-            <a:off x="6949440" y="4636008"/>
-            <a:ext cx="1371600" cy="310896"/>
-          </a:xfrm>
-          <a:prstGeom prst="rect">
-            <a:avLst/>
-          </a:prstGeom>
-          <a:solidFill>
-            <a:srgbClr val="FFFFFF"/>
-          </a:solidFill>
-          <a:ln>
-            <a:noFill/>
-          </a:ln>
-        </p:spPr>
-        <p:txBody>
-          <a:bodyPr wrap="none" lIns="0" tIns="0" rIns="0" bIns="0" anchor="ctr"/>
-          <a:lstStyle/>
-          <a:p>
-            <a:pPr algn="ctr"/>
-            <a:r>
-              <a:rPr lang="ko-KR" sz="1800" b="1">
-                <a:solidFill>
-                  <a:srgbClr val="5865F2"/>
-                </a:solidFill>
-                <a:latin typeface="Calibri"/>
-                <a:ea typeface="Calibri"/>
-              </a:rPr>
-              <a:t>Discord</a:t>
-            </a:r>
-          </a:p>
-        </p:txBody>
-      </p:sp>
-      <p:sp>
-        <p:nvSpPr>
-          <p:cNvPr id="904" name="Discord sub"/>
-          <p:cNvSpPr/>
-          <p:nvPr/>
-        </p:nvSpPr>
-        <p:spPr>
-          <a:xfrm>
-            <a:off x="6949440" y="4956048"/>
-            <a:ext cx="1371600" cy="256032"/>
-          </a:xfrm>
-          <a:prstGeom prst="rect">
-            <a:avLst/>
-          </a:prstGeom>
-          <a:solidFill>
-            <a:srgbClr val="FFFFFF"/>
-          </a:solidFill>
-          <a:ln>
-            <a:noFill/>
-          </a:ln>
-        </p:spPr>
-        <p:txBody>
-          <a:bodyPr wrap="none" lIns="0" tIns="0" rIns="0" bIns="0" anchor="ctr"/>
-          <a:lstStyle/>
-          <a:p>
-            <a:pPr algn="ctr"/>
-            <a:r>
-              <a:rPr lang="ko-KR" sz="1400" b="0">
-                <a:solidFill>
-                  <a:srgbClr val="9E9E9E"/>
-                </a:solidFill>
-                <a:latin typeface="Calibri"/>
-                <a:ea typeface="Calibri"/>
-              </a:rPr>
-              <a:t>한국어 안내</a:t>
-            </a:r>
-          </a:p>
-        </p:txBody>
-      </p:sp>
     </p:spTree>
   </p:cSld>
   <p:clrMapOvr>
@@ -17822,7 +17661,7 @@
                           <a:cs typeface="Calibri"/>
                           <a:sym typeface="Calibri"/>
                         </a:rPr>
-                        <a:t>테스트 정책으로 Discord 연동 확인</a:t>
+                        <a:t>테스트 정책으로 Slack 연동 확인</a:t>
                       </a:r>
                       <a:endParaRPr/>
                     </a:p>

</xml_diff>